<commit_message>
feat: add 场景触发式召回 (contextual recall) to roadmap and pitch deck
- P08 upgraded: Storage ≠ Recall, with Manta GitHub image format as real case
- Added T0 (highest priority): pre-tool-call hook for contextual rule injection
- Updated M2 milestone to include contextual recall
- Pitch deck Slide 3: added '存储 ≠ 召回' pain point
- Pitch deck Slide 7: added contextual recall as core capability
- Added SuperBoss quote: 'Teach Once, Store Forever, Recall Never'
</commit_message>
<xml_diff>
--- a/product/hybrid-workforce-pitch.pptx
+++ b/product/hybrid-workforce-pitch.pptx
@@ -4050,7 +4050,7 @@
                 </a:solidFill>
                 <a:latin typeface="Calibri"/>
               </a:rPr>
-              <a:t>没有培训体系</a:t>
+              <a:t>存储 ≠ 召回</a:t>
             </a:r>
           </a:p>
           <a:p>
@@ -4063,7 +4063,7 @@
               </a:defRPr>
             </a:pPr>
             <a:r>
-              <a:t>同样的错反复犯，新人从零教起</a:t>
+              <a:t>Teach Once, Store Forever, Recall Never</a:t>
             </a:r>
           </a:p>
         </p:txBody>
@@ -4099,19 +4099,19 @@
               </a:defRPr>
             </a:pPr>
             <a:r>
+              <a:t>· Manta 的 Skill 里写了「GitHub issue 图片用 markdown 格式」，但每次都忘，需要反复提醒</a:t>
+            </a:r>
+            <a:br/>
+            <a:r>
+              <a:t>· 规则不是没有，是在 20+ 条中被上下文稀释——Agent 不会像人一样「触景生情」</a:t>
+            </a:r>
+            <a:br/>
+            <a:r>
+              <a:t>· 同一条规则纠正多次，跨 session 后又忘了，每个新 session 从零开始</a:t>
+            </a:r>
+            <a:br/>
+            <a:r>
               <a:t>· 新 QA 加入当天：端口用错、流程不会、用代码审查代替实际运行</a:t>
-            </a:r>
-            <a:br/>
-            <a:r>
-              <a:t>· 新 PM 接手新项目，所有规则、流程都要再重复一遍</a:t>
-            </a:r>
-            <a:br/>
-            <a:r>
-              <a:t>· AGENTS.md 膨胀到 20+ 条规则，关键规则被淹没，读了也记不住</a:t>
-            </a:r>
-            <a:br/>
-            <a:r>
-              <a:t>· 同一条规则纠正多次，跨 session 后又忘了，每个新 session 从零开始</a:t>
             </a:r>
           </a:p>
         </p:txBody>
@@ -5483,7 +5483,7 @@
         <p:spPr>
           <a:xfrm>
             <a:off x="914400" y="1463040"/>
-            <a:ext cx="9144000" cy="457200"/>
+            <a:ext cx="9144000" cy="640080"/>
           </a:xfrm>
           <a:prstGeom prst="rect">
             <a:avLst/>
@@ -5505,7 +5505,11 @@
               </a:defRPr>
             </a:pPr>
             <a:r>
-              <a:t>You speak naturally. Your AI team learns permanently.</a:t>
+              <a:t>Today: Teach Once, Store Forever, Recall Never.</a:t>
+            </a:r>
+            <a:br/>
+            <a:r>
+              <a:t>Tomorrow: Teach Once, Remember Forever.</a:t>
             </a:r>
           </a:p>
         </p:txBody>
@@ -5518,7 +5522,7 @@
         </p:nvSpPr>
         <p:spPr>
           <a:xfrm>
-            <a:off x="1097280" y="2286000"/>
+            <a:off x="1097280" y="2560320"/>
             <a:ext cx="9601200" cy="548640"/>
           </a:xfrm>
           <a:prstGeom prst="rect">
@@ -5532,16 +5536,23 @@
           </a:bodyPr>
           <a:lstStyle/>
           <a:p>
-            <a:pPr algn="l">
-              <a:defRPr sz="2000" b="0">
+            <a:r>
+              <a:rPr sz="2000" b="1">
+                <a:solidFill>
+                  <a:srgbClr val="6C5CE7"/>
+                </a:solidFill>
+                <a:latin typeface="Calibri"/>
+              </a:rPr>
+              <a:t>场景触发式召回 </a:t>
+            </a:r>
+            <a:r>
+              <a:rPr sz="2000">
                 <a:solidFill>
                   <a:srgbClr val="C8C8D2"/>
                 </a:solidFill>
                 <a:latin typeface="Calibri"/>
-              </a:defRPr>
-            </a:pPr>
-            <a:r>
-              <a:t>▸  你说一句话 → 每个 Agent 自己识别相关规则 → 写入行为准则</a:t>
+              </a:rPr>
+              <a:t>— Agent 执行工具前，系统自动注入精准规则（pre-tool-call hook）</a:t>
             </a:r>
           </a:p>
         </p:txBody>
@@ -5554,7 +5565,7 @@
         </p:nvSpPr>
         <p:spPr>
           <a:xfrm>
-            <a:off x="1097280" y="2926080"/>
+            <a:off x="1097280" y="3200400"/>
             <a:ext cx="9601200" cy="548640"/>
           </a:xfrm>
           <a:prstGeom prst="rect">
@@ -5577,7 +5588,7 @@
               </a:defRPr>
             </a:pPr>
             <a:r>
-              <a:t>▸  四层记忆保障：场景触发 / 行为前检查 / 失败记忆召回 / 渐进式强化</a:t>
+              <a:t>▸  你说一句话 → 每个 Agent 自己识别相关规则 → 写入行为准则</a:t>
             </a:r>
           </a:p>
         </p:txBody>
@@ -5590,7 +5601,7 @@
         </p:nvSpPr>
         <p:spPr>
           <a:xfrm>
-            <a:off x="1097280" y="3566160"/>
+            <a:off x="1097280" y="3840480"/>
             <a:ext cx="9601200" cy="548640"/>
           </a:xfrm>
           <a:prstGeom prst="rect">
@@ -5604,23 +5615,16 @@
           </a:bodyPr>
           <a:lstStyle/>
           <a:p>
-            <a:r>
-              <a:rPr sz="2000" b="1">
-                <a:solidFill>
-                  <a:srgbClr val="6C5CE7"/>
-                </a:solidFill>
-                <a:latin typeface="Calibri"/>
-              </a:rPr>
-              <a:t>不改模型，改 Harness </a:t>
-            </a:r>
-            <a:r>
-              <a:rPr sz="2000">
+            <a:pPr algn="l">
+              <a:defRPr sz="2000" b="0">
                 <a:solidFill>
                   <a:srgbClr val="C8C8D2"/>
                 </a:solidFill>
                 <a:latin typeface="Calibri"/>
-              </a:rPr>
-              <a:t>— 轻量、即时、可解释</a:t>
+              </a:defRPr>
+            </a:pPr>
+            <a:r>
+              <a:t>▸  四层记忆保障：场景触发 / 行为前检查 / 失败记忆召回 / 渐进式强化</a:t>
             </a:r>
           </a:p>
         </p:txBody>
@@ -5633,7 +5637,7 @@
         </p:nvSpPr>
         <p:spPr>
           <a:xfrm>
-            <a:off x="1097280" y="4206239"/>
+            <a:off x="1097280" y="4480559"/>
             <a:ext cx="9601200" cy="548640"/>
           </a:xfrm>
           <a:prstGeom prst="rect">
@@ -5647,16 +5651,23 @@
           </a:bodyPr>
           <a:lstStyle/>
           <a:p>
-            <a:pPr algn="l">
-              <a:defRPr sz="2000" b="0">
+            <a:r>
+              <a:rPr sz="2000" b="1">
+                <a:solidFill>
+                  <a:srgbClr val="6C5CE7"/>
+                </a:solidFill>
+                <a:latin typeface="Calibri"/>
+              </a:rPr>
+              <a:t>不改模型，改 Harness </a:t>
+            </a:r>
+            <a:r>
+              <a:rPr sz="2000">
                 <a:solidFill>
                   <a:srgbClr val="C8C8D2"/>
                 </a:solidFill>
                 <a:latin typeface="Calibri"/>
-              </a:defRPr>
-            </a:pPr>
-            <a:r>
-              <a:t>▸  纠正一次同类错误永不再犯，不是提醒，是拦截</a:t>
+              </a:rPr>
+              <a:t>— 轻量、即时、可解释</a:t>
             </a:r>
           </a:p>
         </p:txBody>

</xml_diff>

<commit_message>
Update slogan to three-part format: Teach Once, Recall Instantly, Remember Forever
</commit_message>
<xml_diff>
--- a/product/hybrid-workforce-pitch.pptx
+++ b/product/hybrid-workforce-pitch.pptx
@@ -5469,7 +5469,7 @@
               </a:defRPr>
             </a:pPr>
             <a:r>
-              <a:t>Teach Once, Remember Forever</a:t>
+              <a:t>Teach Once, Recall Instantly, Remember Forever</a:t>
             </a:r>
           </a:p>
         </p:txBody>
@@ -5509,7 +5509,7 @@
             </a:r>
             <a:br/>
             <a:r>
-              <a:t>Tomorrow: Teach Once, Remember Forever.</a:t>
+              <a:t>Tomorrow: Teach Once, Recall Instantly, Remember Forever.</a:t>
             </a:r>
           </a:p>
         </p:txBody>

</xml_diff>